<commit_message>
docs: retouche dossier/PPTX (pieds de page, sous-titre A3) et ignore secrets.h.*
</commit_message>
<xml_diff>
--- a/docs/Workshop2026-M1-G-Pres.pptx
+++ b/docs/Workshop2026-M1-G-Pres.pptx
@@ -4756,7 +4756,7 @@
                 </a:solidFill>
                 <a:latin typeface="Ubuntu"/>
               </a:rPr>
-              <a:t>la sécurité à la bordure.</a:t>
+              <a:t>.</a:t>
             </a:r>
           </a:p>
         </p:txBody>
@@ -15441,7 +15441,7 @@
                 </a:solidFill>
                 <a:latin typeface="Ubuntu"/>
               </a:rPr>
-              <a:t>la sécurité à la bordure.</a:t>
+              <a:t>.</a:t>
             </a:r>
           </a:p>
         </p:txBody>

</xml_diff>